<commit_message>
Teams of at most 5, 10-minute demo slots, repository from template (no fork), shared team list; outputs rebuilt
</commit_message>
<xml_diff>
--- a/docs/prerequisites/cen207-prerequisites-slides.en.pptx
+++ b/docs/prerequisites/cen207-prerequisites-slides.en.pptx
@@ -15127,7 +15127,7 @@
                   <a:srgbClr val="1F2D3A"/>
                 </a:solidFill>
               </a:rPr>
-              <a:t>Used here in: the project guide's workflow (fork, plan, submission) for both checkpoints</a:t>
+              <a:t>Used here in: the project guide's workflow (repository from the template, plan, submission) for both checkpoints</a:t>
             </a:r>
           </a:p>
         </p:txBody>
@@ -15591,7 +15591,7 @@
         <p:spPr>
           <a:xfrm>
             <a:off x="640080" y="1325880"/>
-            <a:ext cx="10911535" cy="1549400"/>
+            <a:ext cx="10911535" cy="1879600"/>
           </a:xfrm>
           <a:prstGeom prst="rect">
             <a:avLst/>
@@ -15623,7 +15623,7 @@
                   <a:srgbClr val="1F2D3A"/>
                 </a:solidFill>
               </a:rPr>
-              <a:t>Forking a template, building it, producing its tests and documentation</a:t>
+              <a:t>Creating a private repository from a template ("Use this template", not fork), building it, producing its tests and documentation</a:t>
             </a:r>
           </a:p>
           <a:p>

</xml_diff>